<commit_message>
[C] Demo video pipeline, updated deck, progress log
Co-Authored-By: Claude Sonnet 5.5 <noreply@anthropic.com>
</commit_message>
<xml_diff>
--- a/docs/presentation/Chartitable.pptx
+++ b/docs/presentation/Chartitable.pptx
@@ -683,7 +683,7 @@
           <a:p>
             <a:r>
               <a:rPr lang="en-US" dirty="0"/>
-              <a:t>One of the biggest problems charities have is donor retention. According to the Fundraising Effectiveness Project, only 43.3% of donors gave again the next year, so more than half never come back. The bucket leaks because donors never see what happened next. Source: https://publications.fepreports.org/archive/2025-q4/retention-time-series/</a:t>
+              <a:t>One of the biggest problems charities have is donor retention. According to the Fundraising Effectiveness Project, only 43.3% of donors gave again the next year, so more than half never come back. And that costs real money: in one year, just the 10,640 charities in FEP's dataset lost $4.6 billion to donors who stopped giving or gave less. There are about 1.6 million 501(c)(3) charities in the US, and every one of them has this same leaky bucket. The bucket leaks because donors never see what happened next. Sources: 43.3% retention - Fundraising Effectiveness Project, Q4 2025, https://publications.fepreports.org/archive/2025-q4/retention-time-series/ . $4.6B - 2019 Fundraising Effectiveness Survey Report (AFP/Urban Institute; 2018 data): gains of $5.009B offset by losses of $4.643B through reduced gifts and lapsed donors across 10,640 US nonprofits, https://afpglobal.org/sites/default/files/attachments/generic/FEP2019AnnualSurveyReport.pdf . 1.6M - IRS Data Book FY2025, Table 2-6: 1,596,231 recognized 501(c)(3) organizations (includes private foundations; excludes churches that never applied), https://www.irs.gov/statistics/soi-tax-stats-tax-exempt-organizations-and-nonexempt-charitable-trusts-irs-data-book-table-2-6 .</a:t>
             </a:r>
             <a:endParaRPr lang="en-US" dirty="0"/>
           </a:p>
@@ -2406,8 +2406,8 @@
         </p:blipFill>
         <p:spPr>
           <a:xfrm rot="-120000">
-            <a:off x="5806440" y="1325880"/>
-            <a:ext cx="6035040" cy="3694176"/>
+            <a:off x="6309360" y="1188720"/>
+            <a:ext cx="5394960" cy="3304859"/>
           </a:xfrm>
           <a:prstGeom prst="rect">
             <a:avLst/>
@@ -2528,7 +2528,7 @@
         </p:nvSpPr>
         <p:spPr>
           <a:xfrm rot="-60000">
-            <a:off x="5897880" y="5138928"/>
+            <a:off x="6355080" y="4553712"/>
             <a:ext cx="4206240" cy="365760"/>
           </a:xfrm>
           <a:prstGeom prst="rect">
@@ -2556,6 +2556,150 @@
               <a:t>source: Fundraising Effectiveness Project, Q4 2025</a:t>
             </a:r>
             <a:endParaRPr lang="en-US" sz="1400" dirty="0"/>
+          </a:p>
+        </p:txBody>
+      </p:sp>
+      <p:sp>
+        <p:nvSpPr>
+          <p:cNvPr id="30" name="Money lost stat"/>
+          <p:cNvSpPr/>
+          <p:nvPr/>
+        </p:nvSpPr>
+        <p:spPr>
+          <a:xfrm rot="-120000">
+            <a:off x="5943600" y="4937760"/>
+            <a:ext cx="2971800" cy="1325880"/>
+          </a:xfrm>
+          <a:prstGeom prst="rect">
+            <a:avLst/>
+          </a:prstGeom>
+          <a:noFill/>
+          <a:ln/>
+        </p:spPr>
+        <p:txBody>
+          <a:bodyPr wrap="square" lIns="45720" tIns="0" rIns="45720" bIns="0" rtlCol="0" anchor="t">
+            <a:normAutofit/>
+          </a:bodyPr>
+          <a:lstStyle/>
+          <a:p>
+            <a:pPr algn="l" indent="0" marL="0">
+              <a:buNone/>
+            </a:pPr>
+            <a:r>
+              <a:rPr lang="en-US" sz="2800" b="1" dirty="0">
+                <a:solidFill>
+                  <a:srgbClr val="FF0000"/>
+                </a:solidFill>
+                <a:latin typeface="Comic Sans MS" pitchFamily="34" charset="0"/>
+                <a:ea typeface="Comic Sans MS" pitchFamily="34" charset="-122"/>
+                <a:cs typeface="Comic Sans MS" pitchFamily="34" charset="-120"/>
+              </a:rPr>
+              <a:t>$4.6 BILLION</a:t>
+            </a:r>
+          </a:p>
+          <a:p>
+            <a:pPr algn="l" indent="0" marL="0">
+              <a:buNone/>
+            </a:pPr>
+            <a:r>
+              <a:rPr lang="en-US" sz="1200" b="1" dirty="0">
+                <a:solidFill>
+                  <a:srgbClr val="000000"/>
+                </a:solidFill>
+                <a:latin typeface="Comic Sans MS" pitchFamily="34" charset="0"/>
+                <a:ea typeface="Comic Sans MS" pitchFamily="34" charset="-122"/>
+                <a:cs typeface="Comic Sans MS" pitchFamily="34" charset="-120"/>
+              </a:rPr>
+              <a:t>lost in 1 yr to donors who left or gave less (just 10,640 charities!!)</a:t>
+            </a:r>
+          </a:p>
+          <a:p>
+            <a:pPr algn="l" indent="0" marL="0">
+              <a:buNone/>
+            </a:pPr>
+            <a:r>
+              <a:rPr lang="en-US" sz="900" b="0" dirty="0">
+                <a:solidFill>
+                  <a:srgbClr val="000000"/>
+                </a:solidFill>
+                <a:latin typeface="Comic Sans MS" pitchFamily="34" charset="0"/>
+                <a:ea typeface="Comic Sans MS" pitchFamily="34" charset="-122"/>
+                <a:cs typeface="Comic Sans MS" pitchFamily="34" charset="-120"/>
+              </a:rPr>
+              <a:t>source: Fundraising Effectiveness Project 2019 report (2018 data)</a:t>
+            </a:r>
+          </a:p>
+        </p:txBody>
+      </p:sp>
+      <p:sp>
+        <p:nvSpPr>
+          <p:cNvPr id="31" name="Charity count stat"/>
+          <p:cNvSpPr/>
+          <p:nvPr/>
+        </p:nvSpPr>
+        <p:spPr>
+          <a:xfrm rot="90000">
+            <a:off x="9006840" y="4892040"/>
+            <a:ext cx="2926080" cy="1325880"/>
+          </a:xfrm>
+          <a:prstGeom prst="rect">
+            <a:avLst/>
+          </a:prstGeom>
+          <a:noFill/>
+          <a:ln/>
+        </p:spPr>
+        <p:txBody>
+          <a:bodyPr wrap="square" lIns="45720" tIns="0" rIns="45720" bIns="0" rtlCol="0" anchor="t">
+            <a:normAutofit/>
+          </a:bodyPr>
+          <a:lstStyle/>
+          <a:p>
+            <a:pPr algn="l" indent="0" marL="0">
+              <a:buNone/>
+            </a:pPr>
+            <a:r>
+              <a:rPr lang="en-US" sz="2800" b="1" dirty="0">
+                <a:solidFill>
+                  <a:srgbClr val="0000FF"/>
+                </a:solidFill>
+                <a:latin typeface="Comic Sans MS" pitchFamily="34" charset="0"/>
+                <a:ea typeface="Comic Sans MS" pitchFamily="34" charset="-122"/>
+                <a:cs typeface="Comic Sans MS" pitchFamily="34" charset="-120"/>
+              </a:rPr>
+              <a:t>~1.6 MILLION</a:t>
+            </a:r>
+          </a:p>
+          <a:p>
+            <a:pPr algn="l" indent="0" marL="0">
+              <a:buNone/>
+            </a:pPr>
+            <a:r>
+              <a:rPr lang="en-US" sz="1200" b="1" dirty="0">
+                <a:solidFill>
+                  <a:srgbClr val="000000"/>
+                </a:solidFill>
+                <a:latin typeface="Comic Sans MS" pitchFamily="34" charset="0"/>
+                <a:ea typeface="Comic Sans MS" pitchFamily="34" charset="-122"/>
+                <a:cs typeface="Comic Sans MS" pitchFamily="34" charset="-120"/>
+              </a:rPr>
+              <a:t>US charities w/ a bucket we could plug</a:t>
+            </a:r>
+          </a:p>
+          <a:p>
+            <a:pPr algn="l" indent="0" marL="0">
+              <a:buNone/>
+            </a:pPr>
+            <a:r>
+              <a:rPr lang="en-US" sz="900" b="0" dirty="0">
+                <a:solidFill>
+                  <a:srgbClr val="000000"/>
+                </a:solidFill>
+                <a:latin typeface="Comic Sans MS" pitchFamily="34" charset="0"/>
+                <a:ea typeface="Comic Sans MS" pitchFamily="34" charset="-122"/>
+                <a:cs typeface="Comic Sans MS" pitchFamily="34" charset="-120"/>
+              </a:rPr>
+              <a:t>source: IRS Data Book FY2025, 501(c)(3) orgs</a:t>
+            </a:r>
           </a:p>
         </p:txBody>
       </p:sp>

</xml_diff>

<commit_message>
[C] Video v2: charity-side dashboard scene, no-caveat script, logo slide; update pitch plan
Co-Authored-By: Claude Sonnet 5.5 <noreply@anthropic.com>
</commit_message>
<xml_diff>
--- a/docs/presentation/Chartitable.pptx
+++ b/docs/presentation/Chartitable.pptx
@@ -3486,8 +3486,8 @@
         </p:blipFill>
         <p:spPr>
           <a:xfrm>
-            <a:off x="822960" y="1005840"/>
-            <a:ext cx="3017520" cy="5102352"/>
+            <a:off x="822960" y="502920"/>
+            <a:ext cx="2920180" cy="4937760"/>
           </a:xfrm>
           <a:prstGeom prst="rect">
             <a:avLst/>
@@ -3510,7 +3510,7 @@
         </p:blipFill>
         <p:spPr>
           <a:xfrm>
-            <a:off x="9966960" y="4297680"/>
+            <a:off x="9966960" y="3520440"/>
             <a:ext cx="1920240" cy="1920240"/>
           </a:xfrm>
           <a:prstGeom prst="rect">
@@ -3526,7 +3526,7 @@
         </p:nvSpPr>
         <p:spPr>
           <a:xfrm rot="-180000">
-            <a:off x="5120640" y="1280160"/>
+            <a:off x="5120640" y="868680"/>
             <a:ext cx="6217920" cy="1005840"/>
           </a:xfrm>
           <a:prstGeom prst="rect">
@@ -3565,7 +3565,7 @@
         </p:nvSpPr>
         <p:spPr>
           <a:xfrm rot="120000">
-            <a:off x="5394960" y="2468880"/>
+            <a:off x="5394960" y="2011680"/>
             <a:ext cx="5943600" cy="1005840"/>
           </a:xfrm>
           <a:prstGeom prst="rect">
@@ -3725,7 +3725,7 @@
         </p:nvSpPr>
         <p:spPr>
           <a:xfrm rot="-120000">
-            <a:off x="5120640" y="3657600"/>
+            <a:off x="5120640" y="3154680"/>
             <a:ext cx="6217920" cy="1005840"/>
           </a:xfrm>
           <a:prstGeom prst="rect">
@@ -3758,13 +3758,274 @@
       </p:sp>
       <p:sp>
         <p:nvSpPr>
+          <p:cNvPr id="90" name="Built with strip"/>
+          <p:cNvSpPr/>
+          <p:nvPr/>
+        </p:nvSpPr>
+        <p:spPr>
+          <a:xfrm>
+            <a:off x="228600" y="5669280"/>
+            <a:ext cx="11731752" cy="777240"/>
+          </a:xfrm>
+          <a:prstGeom prst="rect">
+            <a:avLst/>
+          </a:prstGeom>
+          <a:solidFill>
+            <a:srgbClr val="FFFFFF"/>
+          </a:solidFill>
+          <a:ln w="19050">
+            <a:solidFill>
+              <a:srgbClr val="000000"/>
+            </a:solidFill>
+            <a:prstDash val="dash"/>
+          </a:ln>
+        </p:spPr>
+      </p:sp>
+      <p:sp>
+        <p:nvSpPr>
+          <p:cNvPr id="91" name="Built with label"/>
+          <p:cNvSpPr txBox="1"/>
+          <p:nvPr/>
+        </p:nvSpPr>
+        <p:spPr>
+          <a:xfrm rot="-180000">
+            <a:off x="411480" y="5824728"/>
+            <a:ext cx="1143000" cy="457200"/>
+          </a:xfrm>
+          <a:prstGeom prst="rect">
+            <a:avLst/>
+          </a:prstGeom>
+          <a:noFill/>
+        </p:spPr>
+        <p:txBody>
+          <a:bodyPr wrap="none" lIns="0" tIns="0" rIns="0" bIns="0" anchor="ctr"/>
+          <a:lstStyle/>
+          <a:p>
+            <a:pPr algn="l"/>
+            <a:r>
+              <a:rPr lang="en-US" sz="1800" b="1" dirty="0">
+                <a:solidFill>
+                  <a:srgbClr val="000000"/>
+                </a:solidFill>
+                <a:latin typeface="Comic Sans MS"/>
+                <a:cs typeface="Comic Sans MS"/>
+              </a:rPr>
+              <a:t>built with:</a:t>
+            </a:r>
+          </a:p>
+        </p:txBody>
+      </p:sp>
+      <p:pic>
+        <p:nvPicPr>
+          <p:cNvPr id="92" name="Logo claude" descr="Claude logo"/>
+          <p:cNvPicPr>
+            <a:picLocks noChangeAspect="1"/>
+          </p:cNvPicPr>
+          <p:nvPr/>
+        </p:nvPicPr>
+        <p:blipFill>
+          <a:blip r:embed="rIdLogo0"/>
+          <a:stretch>
+            <a:fillRect/>
+          </a:stretch>
+        </p:blipFill>
+        <p:spPr>
+          <a:xfrm>
+            <a:off x="1768593" y="5920740"/>
+            <a:ext cx="1254998" cy="274320"/>
+          </a:xfrm>
+          <a:prstGeom prst="rect">
+            <a:avLst/>
+          </a:prstGeom>
+        </p:spPr>
+      </p:pic>
+      <p:pic>
+        <p:nvPicPr>
+          <p:cNvPr id="93" name="Logo convex" descr="Convex logo"/>
+          <p:cNvPicPr>
+            <a:picLocks noChangeAspect="1"/>
+          </p:cNvPicPr>
+          <p:nvPr/>
+        </p:nvPicPr>
+        <p:blipFill>
+          <a:blip r:embed="rIdLogo1"/>
+          <a:stretch>
+            <a:fillRect/>
+          </a:stretch>
+        </p:blipFill>
+        <p:spPr>
+          <a:xfrm>
+            <a:off x="3279624" y="5920740"/>
+            <a:ext cx="1517543" cy="274320"/>
+          </a:xfrm>
+          <a:prstGeom prst="rect">
+            <a:avLst/>
+          </a:prstGeom>
+        </p:spPr>
+      </p:pic>
+      <p:pic>
+        <p:nvPicPr>
+          <p:cNvPr id="94" name="Logo vercel" descr="Vercel logo"/>
+          <p:cNvPicPr>
+            <a:picLocks noChangeAspect="1"/>
+          </p:cNvPicPr>
+          <p:nvPr/>
+        </p:nvPicPr>
+        <p:blipFill>
+          <a:blip r:embed="rIdLogo2"/>
+          <a:stretch>
+            <a:fillRect/>
+          </a:stretch>
+        </p:blipFill>
+        <p:spPr>
+          <a:xfrm>
+            <a:off x="5053199" y="5941314"/>
+            <a:ext cx="1167003" cy="233172"/>
+          </a:xfrm>
+          <a:prstGeom prst="rect">
+            <a:avLst/>
+          </a:prstGeom>
+        </p:spPr>
+      </p:pic>
+      <p:pic>
+        <p:nvPicPr>
+          <p:cNvPr id="95" name="Logo cursor" descr="Cursor logo"/>
+          <p:cNvPicPr>
+            <a:picLocks noChangeAspect="1"/>
+          </p:cNvPicPr>
+          <p:nvPr/>
+        </p:nvPicPr>
+        <p:blipFill>
+          <a:blip r:embed="rIdLogo3"/>
+          <a:stretch>
+            <a:fillRect/>
+          </a:stretch>
+        </p:blipFill>
+        <p:spPr>
+          <a:xfrm>
+            <a:off x="6476234" y="5920740"/>
+            <a:ext cx="1153793" cy="274320"/>
+          </a:xfrm>
+          <a:prstGeom prst="rect">
+            <a:avLst/>
+          </a:prstGeom>
+        </p:spPr>
+      </p:pic>
+      <p:pic>
+        <p:nvPicPr>
+          <p:cNvPr id="96" name="Logo resend" descr="Resend logo"/>
+          <p:cNvPicPr>
+            <a:picLocks noChangeAspect="1"/>
+          </p:cNvPicPr>
+          <p:nvPr/>
+        </p:nvPicPr>
+        <p:blipFill>
+          <a:blip r:embed="rIdLogo4"/>
+          <a:stretch>
+            <a:fillRect/>
+          </a:stretch>
+        </p:blipFill>
+        <p:spPr>
+          <a:xfrm>
+            <a:off x="7886059" y="5948172"/>
+            <a:ext cx="1033533" cy="219456"/>
+          </a:xfrm>
+          <a:prstGeom prst="rect">
+            <a:avLst/>
+          </a:prstGeom>
+        </p:spPr>
+      </p:pic>
+      <p:pic>
+        <p:nvPicPr>
+          <p:cNvPr id="97" name="Logo figma" descr="Figma logo"/>
+          <p:cNvPicPr>
+            <a:picLocks noChangeAspect="1"/>
+          </p:cNvPicPr>
+          <p:nvPr/>
+        </p:nvPicPr>
+        <p:blipFill>
+          <a:blip r:embed="rIdLogo5"/>
+          <a:stretch>
+            <a:fillRect/>
+          </a:stretch>
+        </p:blipFill>
+        <p:spPr>
+          <a:xfrm>
+            <a:off x="9175625" y="5913882"/>
+            <a:ext cx="1029849" cy="288036"/>
+          </a:xfrm>
+          <a:prstGeom prst="rect">
+            <a:avLst/>
+          </a:prstGeom>
+        </p:spPr>
+      </p:pic>
+      <p:pic>
+        <p:nvPicPr>
+          <p:cNvPr id="98" name="Logo grokbot" descr="Grok Bot logo mark"/>
+          <p:cNvPicPr>
+            <a:picLocks noChangeAspect="1"/>
+          </p:cNvPicPr>
+          <p:nvPr/>
+        </p:nvPicPr>
+        <p:blipFill>
+          <a:blip r:embed="rIdLogo6"/>
+          <a:stretch>
+            <a:fillRect/>
+          </a:stretch>
+        </p:blipFill>
+        <p:spPr>
+          <a:xfrm>
+            <a:off x="10461506" y="5913882"/>
+            <a:ext cx="288036" cy="288036"/>
+          </a:xfrm>
+          <a:prstGeom prst="rect">
+            <a:avLst/>
+          </a:prstGeom>
+        </p:spPr>
+      </p:pic>
+      <p:sp>
+        <p:nvSpPr>
+          <p:cNvPr id="99" name="Grok Bot name"/>
+          <p:cNvSpPr txBox="1"/>
+          <p:nvPr/>
+        </p:nvSpPr>
+        <p:spPr>
+          <a:xfrm rot="0">
+            <a:off x="10804406" y="5875020"/>
+            <a:ext cx="914400" cy="365760"/>
+          </a:xfrm>
+          <a:prstGeom prst="rect">
+            <a:avLst/>
+          </a:prstGeom>
+          <a:noFill/>
+        </p:spPr>
+        <p:txBody>
+          <a:bodyPr wrap="none" lIns="0" tIns="0" rIns="0" bIns="0" anchor="ctr"/>
+          <a:lstStyle/>
+          <a:p>
+            <a:pPr algn="l"/>
+            <a:r>
+              <a:rPr lang="en-US" sz="1500" b="1" dirty="0">
+                <a:solidFill>
+                  <a:srgbClr val="000000"/>
+                </a:solidFill>
+                <a:latin typeface="Arial"/>
+                <a:cs typeface="Arial"/>
+              </a:rPr>
+              <a:t>Grok Bot</a:t>
+            </a:r>
+          </a:p>
+        </p:txBody>
+      </p:sp>
+      <p:sp>
+        <p:nvSpPr>
           <p:cNvPr id="9" name="Text 3"/>
           <p:cNvSpPr/>
           <p:nvPr/>
         </p:nvSpPr>
         <p:spPr>
           <a:xfrm rot="-180000">
-            <a:off x="9144000" y="6355080"/>
+            <a:off x="9144000" y="6510528"/>
             <a:ext cx="2834640" cy="320040"/>
           </a:xfrm>
           <a:prstGeom prst="rect">

</xml_diff>